<commit_message>
Actualizacion de README.md y diagrama de flujo
</commit_message>
<xml_diff>
--- a/RiA_FlowDiagram.pptx
+++ b/RiA_FlowDiagram.pptx
@@ -243,7 +243,7 @@
           <a:p>
             <a:fld id="{5DB4EF61-A96E-4D29-86F7-4B88846E400C}" type="datetimeFigureOut">
               <a:rPr lang="es-ES" smtClean="0"/>
-              <a:t>02/05/2025</a:t>
+              <a:t>03/05/2025</a:t>
             </a:fld>
             <a:endParaRPr lang="es-ES"/>
           </a:p>
@@ -413,7 +413,7 @@
           <a:p>
             <a:fld id="{5DB4EF61-A96E-4D29-86F7-4B88846E400C}" type="datetimeFigureOut">
               <a:rPr lang="es-ES" smtClean="0"/>
-              <a:t>02/05/2025</a:t>
+              <a:t>03/05/2025</a:t>
             </a:fld>
             <a:endParaRPr lang="es-ES"/>
           </a:p>
@@ -593,7 +593,7 @@
           <a:p>
             <a:fld id="{5DB4EF61-A96E-4D29-86F7-4B88846E400C}" type="datetimeFigureOut">
               <a:rPr lang="es-ES" smtClean="0"/>
-              <a:t>02/05/2025</a:t>
+              <a:t>03/05/2025</a:t>
             </a:fld>
             <a:endParaRPr lang="es-ES"/>
           </a:p>
@@ -763,7 +763,7 @@
           <a:p>
             <a:fld id="{5DB4EF61-A96E-4D29-86F7-4B88846E400C}" type="datetimeFigureOut">
               <a:rPr lang="es-ES" smtClean="0"/>
-              <a:t>02/05/2025</a:t>
+              <a:t>03/05/2025</a:t>
             </a:fld>
             <a:endParaRPr lang="es-ES"/>
           </a:p>
@@ -1009,7 +1009,7 @@
           <a:p>
             <a:fld id="{5DB4EF61-A96E-4D29-86F7-4B88846E400C}" type="datetimeFigureOut">
               <a:rPr lang="es-ES" smtClean="0"/>
-              <a:t>02/05/2025</a:t>
+              <a:t>03/05/2025</a:t>
             </a:fld>
             <a:endParaRPr lang="es-ES"/>
           </a:p>
@@ -1241,7 +1241,7 @@
           <a:p>
             <a:fld id="{5DB4EF61-A96E-4D29-86F7-4B88846E400C}" type="datetimeFigureOut">
               <a:rPr lang="es-ES" smtClean="0"/>
-              <a:t>02/05/2025</a:t>
+              <a:t>03/05/2025</a:t>
             </a:fld>
             <a:endParaRPr lang="es-ES"/>
           </a:p>
@@ -1608,7 +1608,7 @@
           <a:p>
             <a:fld id="{5DB4EF61-A96E-4D29-86F7-4B88846E400C}" type="datetimeFigureOut">
               <a:rPr lang="es-ES" smtClean="0"/>
-              <a:t>02/05/2025</a:t>
+              <a:t>03/05/2025</a:t>
             </a:fld>
             <a:endParaRPr lang="es-ES"/>
           </a:p>
@@ -1726,7 +1726,7 @@
           <a:p>
             <a:fld id="{5DB4EF61-A96E-4D29-86F7-4B88846E400C}" type="datetimeFigureOut">
               <a:rPr lang="es-ES" smtClean="0"/>
-              <a:t>02/05/2025</a:t>
+              <a:t>03/05/2025</a:t>
             </a:fld>
             <a:endParaRPr lang="es-ES"/>
           </a:p>
@@ -1821,7 +1821,7 @@
           <a:p>
             <a:fld id="{5DB4EF61-A96E-4D29-86F7-4B88846E400C}" type="datetimeFigureOut">
               <a:rPr lang="es-ES" smtClean="0"/>
-              <a:t>02/05/2025</a:t>
+              <a:t>03/05/2025</a:t>
             </a:fld>
             <a:endParaRPr lang="es-ES"/>
           </a:p>
@@ -2098,7 +2098,7 @@
           <a:p>
             <a:fld id="{5DB4EF61-A96E-4D29-86F7-4B88846E400C}" type="datetimeFigureOut">
               <a:rPr lang="es-ES" smtClean="0"/>
-              <a:t>02/05/2025</a:t>
+              <a:t>03/05/2025</a:t>
             </a:fld>
             <a:endParaRPr lang="es-ES"/>
           </a:p>
@@ -2351,7 +2351,7 @@
           <a:p>
             <a:fld id="{5DB4EF61-A96E-4D29-86F7-4B88846E400C}" type="datetimeFigureOut">
               <a:rPr lang="es-ES" smtClean="0"/>
-              <a:t>02/05/2025</a:t>
+              <a:t>03/05/2025</a:t>
             </a:fld>
             <a:endParaRPr lang="es-ES"/>
           </a:p>
@@ -2564,7 +2564,7 @@
           <a:p>
             <a:fld id="{5DB4EF61-A96E-4D29-86F7-4B88846E400C}" type="datetimeFigureOut">
               <a:rPr lang="es-ES" smtClean="0"/>
-              <a:t>02/05/2025</a:t>
+              <a:t>03/05/2025</a:t>
             </a:fld>
             <a:endParaRPr lang="es-ES"/>
           </a:p>
@@ -2992,7 +2992,7 @@
         </p:blipFill>
         <p:spPr bwMode="auto">
           <a:xfrm>
-            <a:off x="299978" y="3213218"/>
+            <a:off x="299978" y="1939895"/>
             <a:ext cx="1819379" cy="994531"/>
           </a:xfrm>
           <a:prstGeom prst="rect">
@@ -3031,7 +3031,7 @@
         </p:blipFill>
         <p:spPr bwMode="auto">
           <a:xfrm>
-            <a:off x="454677" y="2055968"/>
+            <a:off x="454677" y="782645"/>
             <a:ext cx="1194661" cy="1157250"/>
           </a:xfrm>
           <a:prstGeom prst="rect">
@@ -3057,7 +3057,7 @@
         </p:nvSpPr>
         <p:spPr>
           <a:xfrm>
-            <a:off x="85459" y="1902144"/>
+            <a:off x="85459" y="628821"/>
             <a:ext cx="2153540" cy="2362207"/>
           </a:xfrm>
           <a:prstGeom prst="roundRect">
@@ -3103,7 +3103,7 @@
         </p:nvCxnSpPr>
         <p:spPr>
           <a:xfrm>
-            <a:off x="2238999" y="3093577"/>
+            <a:off x="2238999" y="1820254"/>
             <a:ext cx="1184989" cy="0"/>
           </a:xfrm>
           <a:prstGeom prst="straightConnector1">
@@ -3111,7 +3111,7 @@
           </a:prstGeom>
           <a:ln w="19050">
             <a:solidFill>
-              <a:schemeClr val="tx1"/>
+              <a:srgbClr val="00B050"/>
             </a:solidFill>
             <a:tailEnd type="triangle"/>
           </a:ln>
@@ -3139,7 +3139,7 @@
         </p:nvSpPr>
         <p:spPr>
           <a:xfrm>
-            <a:off x="2213364" y="3083246"/>
+            <a:off x="2213364" y="1809923"/>
             <a:ext cx="1102399" cy="584775"/>
           </a:xfrm>
           <a:prstGeom prst="rect">
@@ -3155,10 +3155,18 @@
           <a:p>
             <a:pPr algn="ctr"/>
             <a:r>
-              <a:rPr lang="es-ES" sz="1600" dirty="0" smtClean="0"/>
+              <a:rPr lang="es-ES" sz="1600" dirty="0" smtClean="0">
+                <a:solidFill>
+                  <a:srgbClr val="00B050"/>
+                </a:solidFill>
+              </a:rPr>
               <a:t>Download rawdata</a:t>
             </a:r>
-            <a:endParaRPr lang="es-ES" sz="1600" dirty="0"/>
+            <a:endParaRPr lang="es-ES" sz="1600" dirty="0">
+              <a:solidFill>
+                <a:srgbClr val="00B050"/>
+              </a:solidFill>
+            </a:endParaRPr>
           </a:p>
         </p:txBody>
       </p:sp>
@@ -3170,7 +3178,7 @@
         </p:nvSpPr>
         <p:spPr>
           <a:xfrm>
-            <a:off x="3423988" y="1912473"/>
+            <a:off x="3423988" y="639150"/>
             <a:ext cx="2640651" cy="2362207"/>
           </a:xfrm>
           <a:prstGeom prst="roundRect">
@@ -3231,7 +3239,7 @@
         </p:blipFill>
         <p:spPr bwMode="auto">
           <a:xfrm>
-            <a:off x="3560228" y="2120935"/>
+            <a:off x="3560228" y="847612"/>
             <a:ext cx="2368170" cy="1945282"/>
           </a:xfrm>
           <a:prstGeom prst="rect">
@@ -3257,7 +3265,7 @@
         </p:nvSpPr>
         <p:spPr>
           <a:xfrm>
-            <a:off x="8908385" y="2423151"/>
+            <a:off x="9496999" y="3183574"/>
             <a:ext cx="1145136" cy="584775"/>
           </a:xfrm>
           <a:prstGeom prst="rect">
@@ -3273,10 +3281,32 @@
           <a:p>
             <a:pPr algn="ctr"/>
             <a:r>
-              <a:rPr lang="es-ES" sz="1600" dirty="0" smtClean="0"/>
-              <a:t>Production model</a:t>
-            </a:r>
-            <a:endParaRPr lang="es-ES" sz="1600" dirty="0"/>
+              <a:rPr lang="es-ES" sz="1600" dirty="0" smtClean="0">
+                <a:solidFill>
+                  <a:schemeClr val="accent4">
+                    <a:lumMod val="75000"/>
+                  </a:schemeClr>
+                </a:solidFill>
+              </a:rPr>
+              <a:t>Production </a:t>
+            </a:r>
+            <a:r>
+              <a:rPr lang="es-ES" sz="1600" dirty="0" err="1" smtClean="0">
+                <a:solidFill>
+                  <a:schemeClr val="accent4">
+                    <a:lumMod val="75000"/>
+                  </a:schemeClr>
+                </a:solidFill>
+              </a:rPr>
+              <a:t>model</a:t>
+            </a:r>
+            <a:endParaRPr lang="es-ES" sz="1600" dirty="0">
+              <a:solidFill>
+                <a:schemeClr val="accent4">
+                  <a:lumMod val="75000"/>
+                </a:schemeClr>
+              </a:solidFill>
+            </a:endParaRPr>
           </a:p>
         </p:txBody>
       </p:sp>
@@ -3288,7 +3318,7 @@
         </p:nvSpPr>
         <p:spPr>
           <a:xfrm>
-            <a:off x="7409200" y="1902143"/>
+            <a:off x="7409200" y="628820"/>
             <a:ext cx="1444244" cy="2362207"/>
           </a:xfrm>
           <a:prstGeom prst="roundRect">
@@ -3347,7 +3377,7 @@
         </p:blipFill>
         <p:spPr bwMode="auto">
           <a:xfrm>
-            <a:off x="7455660" y="2055237"/>
+            <a:off x="7455660" y="781914"/>
             <a:ext cx="1183962" cy="2037762"/>
           </a:xfrm>
           <a:prstGeom prst="rect">
@@ -3373,7 +3403,7 @@
         </p:nvCxnSpPr>
         <p:spPr>
           <a:xfrm flipV="1">
-            <a:off x="6067461" y="2502583"/>
+            <a:off x="6067461" y="1229260"/>
             <a:ext cx="1337499" cy="1"/>
           </a:xfrm>
           <a:prstGeom prst="straightConnector1">
@@ -3381,7 +3411,7 @@
           </a:prstGeom>
           <a:ln w="19050">
             <a:solidFill>
-              <a:schemeClr val="tx1"/>
+              <a:srgbClr val="00B050"/>
             </a:solidFill>
             <a:tailEnd type="triangle"/>
           </a:ln>
@@ -3409,7 +3439,7 @@
         </p:nvSpPr>
         <p:spPr>
           <a:xfrm>
-            <a:off x="6118161" y="1912473"/>
+            <a:off x="6118161" y="639150"/>
             <a:ext cx="1236098" cy="584775"/>
           </a:xfrm>
           <a:prstGeom prst="rect">
@@ -3425,10 +3455,18 @@
           <a:p>
             <a:pPr algn="ctr"/>
             <a:r>
-              <a:rPr lang="es-ES" sz="1600" dirty="0" smtClean="0"/>
+              <a:rPr lang="es-ES" sz="1600" dirty="0" smtClean="0">
+                <a:solidFill>
+                  <a:srgbClr val="00B050"/>
+                </a:solidFill>
+              </a:rPr>
               <a:t>Save &amp; Load rawdata</a:t>
             </a:r>
-            <a:endParaRPr lang="es-ES" sz="1600" dirty="0"/>
+            <a:endParaRPr lang="es-ES" sz="1600" dirty="0">
+              <a:solidFill>
+                <a:srgbClr val="00B050"/>
+              </a:solidFill>
+            </a:endParaRPr>
           </a:p>
         </p:txBody>
       </p:sp>
@@ -3440,7 +3478,7 @@
         </p:nvCxnSpPr>
         <p:spPr>
           <a:xfrm flipH="1">
-            <a:off x="6047055" y="2663679"/>
+            <a:off x="6047055" y="1390356"/>
             <a:ext cx="1350844" cy="0"/>
           </a:xfrm>
           <a:prstGeom prst="straightConnector1">
@@ -3448,7 +3486,7 @@
           </a:prstGeom>
           <a:ln w="19050">
             <a:solidFill>
-              <a:schemeClr val="tx1"/>
+              <a:srgbClr val="00B050"/>
             </a:solidFill>
             <a:tailEnd type="triangle"/>
           </a:ln>
@@ -3476,7 +3514,7 @@
         </p:nvCxnSpPr>
         <p:spPr>
           <a:xfrm flipV="1">
-            <a:off x="6074522" y="3419548"/>
+            <a:off x="6074522" y="2146225"/>
             <a:ext cx="1337499" cy="1"/>
           </a:xfrm>
           <a:prstGeom prst="straightConnector1">
@@ -3484,7 +3522,7 @@
           </a:prstGeom>
           <a:ln w="19050">
             <a:solidFill>
-              <a:schemeClr val="tx1"/>
+              <a:srgbClr val="00B050"/>
             </a:solidFill>
             <a:tailEnd type="triangle"/>
           </a:ln>
@@ -3512,7 +3550,7 @@
         </p:nvSpPr>
         <p:spPr>
           <a:xfrm>
-            <a:off x="6118161" y="3634773"/>
+            <a:off x="6118161" y="2361450"/>
             <a:ext cx="1236098" cy="830997"/>
           </a:xfrm>
           <a:prstGeom prst="rect">
@@ -3528,10 +3566,18 @@
           <a:p>
             <a:pPr algn="ctr"/>
             <a:r>
-              <a:rPr lang="es-ES" sz="1600" dirty="0" smtClean="0"/>
+              <a:rPr lang="es-ES" sz="1600" dirty="0" smtClean="0">
+                <a:solidFill>
+                  <a:srgbClr val="00B050"/>
+                </a:solidFill>
+              </a:rPr>
               <a:t>Split, Transform &amp; Save data</a:t>
             </a:r>
-            <a:endParaRPr lang="es-ES" sz="1600" dirty="0"/>
+            <a:endParaRPr lang="es-ES" sz="1600" dirty="0">
+              <a:solidFill>
+                <a:srgbClr val="00B050"/>
+              </a:solidFill>
+            </a:endParaRPr>
           </a:p>
         </p:txBody>
       </p:sp>
@@ -3543,7 +3589,7 @@
         </p:nvCxnSpPr>
         <p:spPr>
           <a:xfrm flipH="1">
-            <a:off x="6054116" y="3580644"/>
+            <a:off x="6054116" y="2307321"/>
             <a:ext cx="1350844" cy="0"/>
           </a:xfrm>
           <a:prstGeom prst="straightConnector1">
@@ -3551,7 +3597,7 @@
           </a:prstGeom>
           <a:ln w="19050">
             <a:solidFill>
-              <a:schemeClr val="tx1"/>
+              <a:srgbClr val="00B050"/>
             </a:solidFill>
             <a:tailEnd type="triangle"/>
           </a:ln>
@@ -3579,7 +3625,7 @@
         </p:nvSpPr>
         <p:spPr>
           <a:xfrm>
-            <a:off x="3798554" y="5181314"/>
+            <a:off x="213043" y="3957848"/>
             <a:ext cx="1583018" cy="1456351"/>
           </a:xfrm>
           <a:prstGeom prst="roundRect">
@@ -3640,7 +3686,7 @@
         </p:blipFill>
         <p:spPr bwMode="auto">
           <a:xfrm>
-            <a:off x="4093914" y="5338009"/>
+            <a:off x="504573" y="4020197"/>
             <a:ext cx="985582" cy="1142963"/>
           </a:xfrm>
           <a:prstGeom prst="rect">
@@ -3661,20 +3707,23 @@
       <p:cxnSp>
         <p:nvCxnSpPr>
           <p:cNvPr id="37" name="Conector recto de flecha 36"/>
-          <p:cNvCxnSpPr/>
+          <p:cNvCxnSpPr>
+            <a:stCxn id="33" idx="3"/>
+            <a:endCxn id="39" idx="1"/>
+          </p:cNvCxnSpPr>
           <p:nvPr/>
         </p:nvCxnSpPr>
         <p:spPr>
-          <a:xfrm>
-            <a:off x="5381572" y="5909489"/>
-            <a:ext cx="1643071" cy="0"/>
+          <a:xfrm flipV="1">
+            <a:off x="1796061" y="4635520"/>
+            <a:ext cx="4974700" cy="50504"/>
           </a:xfrm>
           <a:prstGeom prst="straightConnector1">
             <a:avLst/>
           </a:prstGeom>
           <a:ln w="19050">
             <a:solidFill>
-              <a:schemeClr val="tx1"/>
+              <a:srgbClr val="0070C0"/>
             </a:solidFill>
             <a:tailEnd type="triangle"/>
           </a:ln>
@@ -3702,7 +3751,7 @@
         </p:nvSpPr>
         <p:spPr>
           <a:xfrm>
-            <a:off x="5310684" y="5570935"/>
+            <a:off x="1721343" y="4253123"/>
             <a:ext cx="1533545" cy="338554"/>
           </a:xfrm>
           <a:prstGeom prst="rect">
@@ -3718,10 +3767,18 @@
           <a:p>
             <a:pPr algn="ctr"/>
             <a:r>
-              <a:rPr lang="es-ES" sz="1600" dirty="0" smtClean="0"/>
+              <a:rPr lang="es-ES" sz="1600" dirty="0" smtClean="0">
+                <a:solidFill>
+                  <a:srgbClr val="0070C0"/>
+                </a:solidFill>
+              </a:rPr>
               <a:t>Load models</a:t>
             </a:r>
-            <a:endParaRPr lang="es-ES" sz="1600" dirty="0"/>
+            <a:endParaRPr lang="es-ES" sz="1600" dirty="0">
+              <a:solidFill>
+                <a:srgbClr val="0070C0"/>
+              </a:solidFill>
+            </a:endParaRPr>
           </a:p>
         </p:txBody>
       </p:sp>
@@ -3733,7 +3790,7 @@
         </p:nvSpPr>
         <p:spPr>
           <a:xfrm>
-            <a:off x="7065207" y="5329544"/>
+            <a:off x="6770761" y="4047021"/>
             <a:ext cx="2164251" cy="1176998"/>
           </a:xfrm>
           <a:prstGeom prst="roundRect">
@@ -3774,14 +3831,12 @@
       <p:cxnSp>
         <p:nvCxnSpPr>
           <p:cNvPr id="41" name="Conector recto de flecha 40"/>
-          <p:cNvCxnSpPr>
-            <a:stCxn id="39" idx="0"/>
-          </p:cNvCxnSpPr>
+          <p:cNvCxnSpPr/>
           <p:nvPr/>
         </p:nvCxnSpPr>
         <p:spPr>
           <a:xfrm flipH="1" flipV="1">
-            <a:off x="8141579" y="4264352"/>
+            <a:off x="7851003" y="2974531"/>
             <a:ext cx="5754" cy="1065192"/>
           </a:xfrm>
           <a:prstGeom prst="straightConnector1">
@@ -3789,7 +3844,7 @@
           </a:prstGeom>
           <a:ln w="19050">
             <a:solidFill>
-              <a:schemeClr val="tx1"/>
+              <a:srgbClr val="0070C0"/>
             </a:solidFill>
             <a:tailEnd type="triangle"/>
           </a:ln>
@@ -3830,7 +3885,7 @@
         </p:blipFill>
         <p:spPr bwMode="auto">
           <a:xfrm>
-            <a:off x="7146305" y="5498214"/>
+            <a:off x="6851859" y="4215691"/>
             <a:ext cx="1997196" cy="808991"/>
           </a:xfrm>
           <a:prstGeom prst="rect">
@@ -3856,7 +3911,7 @@
         </p:nvSpPr>
         <p:spPr>
           <a:xfrm>
-            <a:off x="8047641" y="4552050"/>
+            <a:off x="6317458" y="3299079"/>
             <a:ext cx="1533545" cy="584775"/>
           </a:xfrm>
           <a:prstGeom prst="rect">
@@ -3872,32 +3927,147 @@
           <a:p>
             <a:pPr algn="ctr"/>
             <a:r>
-              <a:rPr lang="es-ES" sz="1600" dirty="0" smtClean="0"/>
+              <a:rPr lang="es-ES" sz="1600" dirty="0" smtClean="0">
+                <a:solidFill>
+                  <a:srgbClr val="0070C0"/>
+                </a:solidFill>
+              </a:rPr>
               <a:t>Save models &amp; experiments</a:t>
             </a:r>
-            <a:endParaRPr lang="es-ES" sz="1600" dirty="0"/>
-          </a:p>
-        </p:txBody>
-      </p:sp>
-      <p:cxnSp>
-        <p:nvCxnSpPr>
-          <p:cNvPr id="52" name="Conector recto de flecha 51"/>
-          <p:cNvCxnSpPr/>
+            <a:endParaRPr lang="es-ES" sz="1600" dirty="0">
+              <a:solidFill>
+                <a:srgbClr val="0070C0"/>
+              </a:solidFill>
+            </a:endParaRPr>
+          </a:p>
+        </p:txBody>
+      </p:sp>
+      <p:sp>
+        <p:nvSpPr>
+          <p:cNvPr id="54" name="Rectángulo redondeado 53"/>
+          <p:cNvSpPr/>
           <p:nvPr/>
-        </p:nvCxnSpPr>
-        <p:spPr>
-          <a:xfrm flipV="1">
-            <a:off x="8860506" y="3007926"/>
-            <a:ext cx="1337499" cy="1"/>
-          </a:xfrm>
-          <a:prstGeom prst="straightConnector1">
+        </p:nvSpPr>
+        <p:spPr>
+          <a:xfrm>
+            <a:off x="10188122" y="781913"/>
+            <a:ext cx="1690532" cy="1696367"/>
+          </a:xfrm>
+          <a:prstGeom prst="roundRect">
             <a:avLst/>
           </a:prstGeom>
+          <a:noFill/>
           <a:ln w="19050">
             <a:solidFill>
               <a:schemeClr val="tx1"/>
             </a:solidFill>
-            <a:tailEnd type="triangle"/>
+          </a:ln>
+        </p:spPr>
+        <p:style>
+          <a:lnRef idx="2">
+            <a:schemeClr val="accent1">
+              <a:shade val="50000"/>
+            </a:schemeClr>
+          </a:lnRef>
+          <a:fillRef idx="1">
+            <a:schemeClr val="accent1"/>
+          </a:fillRef>
+          <a:effectRef idx="0">
+            <a:schemeClr val="accent1"/>
+          </a:effectRef>
+          <a:fontRef idx="minor">
+            <a:schemeClr val="lt1"/>
+          </a:fontRef>
+        </p:style>
+        <p:txBody>
+          <a:bodyPr rtlCol="0" anchor="ctr"/>
+          <a:lstStyle/>
+          <a:p>
+            <a:pPr algn="ctr"/>
+            <a:endParaRPr lang="es-ES" dirty="0"/>
+          </a:p>
+        </p:txBody>
+      </p:sp>
+      <p:pic>
+        <p:nvPicPr>
+          <p:cNvPr id="2" name="Imagen 1"/>
+          <p:cNvPicPr>
+            <a:picLocks noChangeAspect="1"/>
+          </p:cNvPicPr>
+          <p:nvPr/>
+        </p:nvPicPr>
+        <p:blipFill>
+          <a:blip r:embed="rId8"/>
+          <a:stretch>
+            <a:fillRect/>
+          </a:stretch>
+        </p:blipFill>
+        <p:spPr>
+          <a:xfrm>
+            <a:off x="10332606" y="1007503"/>
+            <a:ext cx="1457604" cy="1275759"/>
+          </a:xfrm>
+          <a:prstGeom prst="rect">
+            <a:avLst/>
+          </a:prstGeom>
+        </p:spPr>
+      </p:pic>
+      <p:sp>
+        <p:nvSpPr>
+          <p:cNvPr id="35" name="CuadroTexto 34"/>
+          <p:cNvSpPr txBox="1"/>
+          <p:nvPr/>
+        </p:nvSpPr>
+        <p:spPr>
+          <a:xfrm>
+            <a:off x="991555" y="5557959"/>
+            <a:ext cx="1668136" cy="338554"/>
+          </a:xfrm>
+          <a:prstGeom prst="rect">
+            <a:avLst/>
+          </a:prstGeom>
+          <a:noFill/>
+        </p:spPr>
+        <p:txBody>
+          <a:bodyPr wrap="square" rtlCol="0">
+            <a:spAutoFit/>
+          </a:bodyPr>
+          <a:lstStyle/>
+          <a:p>
+            <a:r>
+              <a:rPr lang="es-ES" sz="1600" dirty="0" smtClean="0">
+                <a:solidFill>
+                  <a:srgbClr val="00B050"/>
+                </a:solidFill>
+              </a:rPr>
+              <a:t>ETL process</a:t>
+            </a:r>
+            <a:endParaRPr lang="es-ES" sz="1600" dirty="0">
+              <a:solidFill>
+                <a:srgbClr val="00B050"/>
+              </a:solidFill>
+            </a:endParaRPr>
+          </a:p>
+        </p:txBody>
+      </p:sp>
+      <p:cxnSp>
+        <p:nvCxnSpPr>
+          <p:cNvPr id="5" name="Conector recto 4"/>
+          <p:cNvCxnSpPr/>
+          <p:nvPr/>
+        </p:nvCxnSpPr>
+        <p:spPr>
+          <a:xfrm>
+            <a:off x="299978" y="5711994"/>
+            <a:ext cx="623843" cy="0"/>
+          </a:xfrm>
+          <a:prstGeom prst="line">
+            <a:avLst/>
+          </a:prstGeom>
+          <a:ln w="28575">
+            <a:solidFill>
+              <a:srgbClr val="00B050"/>
+            </a:solidFill>
           </a:ln>
         </p:spPr>
         <p:style>
@@ -3915,16 +4085,326 @@
           </a:fontRef>
         </p:style>
       </p:cxnSp>
+      <p:sp>
+        <p:nvSpPr>
+          <p:cNvPr id="36" name="CuadroTexto 35"/>
+          <p:cNvSpPr txBox="1"/>
+          <p:nvPr/>
+        </p:nvSpPr>
+        <p:spPr>
+          <a:xfrm>
+            <a:off x="991555" y="5836616"/>
+            <a:ext cx="3264613" cy="338554"/>
+          </a:xfrm>
+          <a:prstGeom prst="rect">
+            <a:avLst/>
+          </a:prstGeom>
+          <a:noFill/>
+        </p:spPr>
+        <p:txBody>
+          <a:bodyPr wrap="square" rtlCol="0">
+            <a:spAutoFit/>
+          </a:bodyPr>
+          <a:lstStyle/>
+          <a:p>
+            <a:r>
+              <a:rPr lang="es-ES" sz="1600" dirty="0" smtClean="0">
+                <a:solidFill>
+                  <a:srgbClr val="0070C0"/>
+                </a:solidFill>
+              </a:rPr>
+              <a:t>Model experimentation process</a:t>
+            </a:r>
+            <a:endParaRPr lang="es-ES" sz="1600" dirty="0">
+              <a:solidFill>
+                <a:srgbClr val="0070C0"/>
+              </a:solidFill>
+            </a:endParaRPr>
+          </a:p>
+        </p:txBody>
+      </p:sp>
+      <p:cxnSp>
+        <p:nvCxnSpPr>
+          <p:cNvPr id="40" name="Conector recto 39"/>
+          <p:cNvCxnSpPr/>
+          <p:nvPr/>
+        </p:nvCxnSpPr>
+        <p:spPr>
+          <a:xfrm>
+            <a:off x="299978" y="6028536"/>
+            <a:ext cx="623843" cy="0"/>
+          </a:xfrm>
+          <a:prstGeom prst="line">
+            <a:avLst/>
+          </a:prstGeom>
+          <a:ln w="28575">
+            <a:solidFill>
+              <a:srgbClr val="0070C0"/>
+            </a:solidFill>
+          </a:ln>
+        </p:spPr>
+        <p:style>
+          <a:lnRef idx="1">
+            <a:schemeClr val="accent1"/>
+          </a:lnRef>
+          <a:fillRef idx="0">
+            <a:schemeClr val="accent1"/>
+          </a:fillRef>
+          <a:effectRef idx="0">
+            <a:schemeClr val="accent1"/>
+          </a:effectRef>
+          <a:fontRef idx="minor">
+            <a:schemeClr val="tx1"/>
+          </a:fontRef>
+        </p:style>
+      </p:cxnSp>
+      <p:cxnSp>
+        <p:nvCxnSpPr>
+          <p:cNvPr id="11" name="Conector angular 10"/>
+          <p:cNvCxnSpPr>
+            <a:stCxn id="39" idx="3"/>
+          </p:cNvCxnSpPr>
+          <p:nvPr/>
+        </p:nvCxnSpPr>
+        <p:spPr>
+          <a:xfrm flipV="1">
+            <a:off x="8935012" y="2462510"/>
+            <a:ext cx="2109677" cy="2173010"/>
+          </a:xfrm>
+          <a:prstGeom prst="bentConnector2">
+            <a:avLst/>
+          </a:prstGeom>
+          <a:ln w="28575">
+            <a:solidFill>
+              <a:srgbClr val="FFC000"/>
+            </a:solidFill>
+            <a:tailEnd type="triangle"/>
+          </a:ln>
+        </p:spPr>
+        <p:style>
+          <a:lnRef idx="1">
+            <a:schemeClr val="accent1"/>
+          </a:lnRef>
+          <a:fillRef idx="0">
+            <a:schemeClr val="accent1"/>
+          </a:fillRef>
+          <a:effectRef idx="0">
+            <a:schemeClr val="accent1"/>
+          </a:effectRef>
+          <a:fontRef idx="minor">
+            <a:schemeClr val="tx1"/>
+          </a:fontRef>
+        </p:style>
+      </p:cxnSp>
+      <p:cxnSp>
+        <p:nvCxnSpPr>
+          <p:cNvPr id="42" name="Conector angular 41"/>
+          <p:cNvCxnSpPr/>
+          <p:nvPr/>
+        </p:nvCxnSpPr>
+        <p:spPr>
+          <a:xfrm rot="5400000">
+            <a:off x="8852556" y="2638726"/>
+            <a:ext cx="1959910" cy="1700162"/>
+          </a:xfrm>
+          <a:prstGeom prst="bentConnector3">
+            <a:avLst>
+              <a:gd name="adj1" fmla="val 100143"/>
+            </a:avLst>
+          </a:prstGeom>
+          <a:ln w="28575">
+            <a:solidFill>
+              <a:srgbClr val="FFC000"/>
+            </a:solidFill>
+            <a:tailEnd type="triangle"/>
+          </a:ln>
+        </p:spPr>
+        <p:style>
+          <a:lnRef idx="1">
+            <a:schemeClr val="accent1"/>
+          </a:lnRef>
+          <a:fillRef idx="0">
+            <a:schemeClr val="accent1"/>
+          </a:fillRef>
+          <a:effectRef idx="0">
+            <a:schemeClr val="accent1"/>
+          </a:effectRef>
+          <a:fontRef idx="minor">
+            <a:schemeClr val="tx1"/>
+          </a:fontRef>
+        </p:style>
+      </p:cxnSp>
+      <p:sp>
+        <p:nvSpPr>
+          <p:cNvPr id="48" name="CuadroTexto 47"/>
+          <p:cNvSpPr txBox="1"/>
+          <p:nvPr/>
+        </p:nvSpPr>
+        <p:spPr>
+          <a:xfrm>
+            <a:off x="11041547" y="3299079"/>
+            <a:ext cx="878720" cy="338554"/>
+          </a:xfrm>
+          <a:prstGeom prst="rect">
+            <a:avLst/>
+          </a:prstGeom>
+          <a:noFill/>
+        </p:spPr>
+        <p:txBody>
+          <a:bodyPr wrap="square" rtlCol="0">
+            <a:spAutoFit/>
+          </a:bodyPr>
+          <a:lstStyle/>
+          <a:p>
+            <a:pPr algn="ctr"/>
+            <a:r>
+              <a:rPr lang="es-ES" sz="1600" dirty="0" err="1" smtClean="0">
+                <a:solidFill>
+                  <a:schemeClr val="accent4">
+                    <a:lumMod val="75000"/>
+                  </a:schemeClr>
+                </a:solidFill>
+              </a:rPr>
+              <a:t>Request</a:t>
+            </a:r>
+            <a:endParaRPr lang="es-ES" sz="1600" dirty="0">
+              <a:solidFill>
+                <a:schemeClr val="accent4">
+                  <a:lumMod val="75000"/>
+                </a:schemeClr>
+              </a:solidFill>
+            </a:endParaRPr>
+          </a:p>
+        </p:txBody>
+      </p:sp>
+      <p:cxnSp>
+        <p:nvCxnSpPr>
+          <p:cNvPr id="55" name="Conector recto de flecha 54"/>
+          <p:cNvCxnSpPr/>
+          <p:nvPr/>
+        </p:nvCxnSpPr>
+        <p:spPr>
+          <a:xfrm flipV="1">
+            <a:off x="8518340" y="3001357"/>
+            <a:ext cx="1" cy="1038366"/>
+          </a:xfrm>
+          <a:prstGeom prst="straightConnector1">
+            <a:avLst/>
+          </a:prstGeom>
+          <a:ln w="19050">
+            <a:solidFill>
+              <a:srgbClr val="FFC000"/>
+            </a:solidFill>
+            <a:tailEnd type="triangle"/>
+          </a:ln>
+        </p:spPr>
+        <p:style>
+          <a:lnRef idx="1">
+            <a:schemeClr val="accent1"/>
+          </a:lnRef>
+          <a:fillRef idx="0">
+            <a:schemeClr val="accent1"/>
+          </a:fillRef>
+          <a:effectRef idx="0">
+            <a:schemeClr val="accent1"/>
+          </a:effectRef>
+          <a:fontRef idx="minor">
+            <a:schemeClr val="tx1"/>
+          </a:fontRef>
+        </p:style>
+      </p:cxnSp>
+      <p:cxnSp>
+        <p:nvCxnSpPr>
+          <p:cNvPr id="56" name="Conector recto de flecha 55"/>
+          <p:cNvCxnSpPr/>
+          <p:nvPr/>
+        </p:nvCxnSpPr>
+        <p:spPr>
+          <a:xfrm>
+            <a:off x="8384966" y="2991027"/>
+            <a:ext cx="0" cy="1065194"/>
+          </a:xfrm>
+          <a:prstGeom prst="straightConnector1">
+            <a:avLst/>
+          </a:prstGeom>
+          <a:ln w="19050">
+            <a:solidFill>
+              <a:srgbClr val="FFC000"/>
+            </a:solidFill>
+            <a:tailEnd type="triangle"/>
+          </a:ln>
+        </p:spPr>
+        <p:style>
+          <a:lnRef idx="1">
+            <a:schemeClr val="accent1"/>
+          </a:lnRef>
+          <a:fillRef idx="0">
+            <a:schemeClr val="accent1"/>
+          </a:fillRef>
+          <a:effectRef idx="0">
+            <a:schemeClr val="accent1"/>
+          </a:effectRef>
+          <a:fontRef idx="minor">
+            <a:schemeClr val="tx1"/>
+          </a:fontRef>
+        </p:style>
+      </p:cxnSp>
+      <p:sp>
+        <p:nvSpPr>
+          <p:cNvPr id="49" name="Rectángulo redondeado 48"/>
+          <p:cNvSpPr/>
+          <p:nvPr/>
+        </p:nvSpPr>
+        <p:spPr>
+          <a:xfrm>
+            <a:off x="3254888" y="273466"/>
+            <a:ext cx="8751953" cy="5170205"/>
+          </a:xfrm>
+          <a:prstGeom prst="roundRect">
+            <a:avLst/>
+          </a:prstGeom>
+          <a:noFill/>
+          <a:ln w="19050">
+            <a:solidFill>
+              <a:schemeClr val="tx1"/>
+            </a:solidFill>
+          </a:ln>
+        </p:spPr>
+        <p:style>
+          <a:lnRef idx="2">
+            <a:schemeClr val="accent1">
+              <a:shade val="50000"/>
+            </a:schemeClr>
+          </a:lnRef>
+          <a:fillRef idx="1">
+            <a:schemeClr val="accent1"/>
+          </a:fillRef>
+          <a:effectRef idx="0">
+            <a:schemeClr val="accent1"/>
+          </a:effectRef>
+          <a:fontRef idx="minor">
+            <a:schemeClr val="lt1"/>
+          </a:fontRef>
+        </p:style>
+        <p:txBody>
+          <a:bodyPr rtlCol="0" anchor="ctr"/>
+          <a:lstStyle/>
+          <a:p>
+            <a:pPr algn="ctr"/>
+            <a:endParaRPr lang="es-ES"/>
+          </a:p>
+        </p:txBody>
+      </p:sp>
       <p:pic>
         <p:nvPicPr>
-          <p:cNvPr id="1044" name="Picture 20" descr="Aprende FastAPI desde 0"/>
+          <p:cNvPr id="53" name="Picture 2" descr="Primeros pasos con Docker para Windows - Daniel Córdoba Cárdenas"/>
           <p:cNvPicPr>
             <a:picLocks noChangeAspect="1" noChangeArrowheads="1"/>
           </p:cNvPicPr>
           <p:nvPr/>
         </p:nvPicPr>
         <p:blipFill>
-          <a:blip r:embed="rId8" cstate="print">
+          <a:blip r:embed="rId9">
             <a:extLst>
               <a:ext uri="{28A0092B-C50C-407E-A947-70E740481C1C}">
                 <a14:useLocalDpi xmlns:a14="http://schemas.microsoft.com/office/drawing/2010/main" val="0"/>
@@ -3938,8 +4418,8 @@
         </p:blipFill>
         <p:spPr bwMode="auto">
           <a:xfrm>
-            <a:off x="10108462" y="2634593"/>
-            <a:ext cx="2025082" cy="730455"/>
+            <a:off x="8905676" y="5378557"/>
+            <a:ext cx="1405052" cy="1200149"/>
           </a:xfrm>
           <a:prstGeom prst="rect">
             <a:avLst/>
@@ -3958,50 +4438,81 @@
       </p:pic>
       <p:sp>
         <p:nvSpPr>
-          <p:cNvPr id="54" name="Rectángulo redondeado 53"/>
-          <p:cNvSpPr/>
+          <p:cNvPr id="71" name="CuadroTexto 70"/>
+          <p:cNvSpPr txBox="1"/>
           <p:nvPr/>
         </p:nvSpPr>
         <p:spPr>
           <a:xfrm>
-            <a:off x="10188122" y="2642698"/>
-            <a:ext cx="1878540" cy="730455"/>
-          </a:xfrm>
-          <a:prstGeom prst="roundRect">
+            <a:off x="991555" y="6162426"/>
+            <a:ext cx="1820011" cy="338554"/>
+          </a:xfrm>
+          <a:prstGeom prst="rect">
             <a:avLst/>
           </a:prstGeom>
           <a:noFill/>
-          <a:ln w="19050">
+        </p:spPr>
+        <p:txBody>
+          <a:bodyPr wrap="square" rtlCol="0">
+            <a:spAutoFit/>
+          </a:bodyPr>
+          <a:lstStyle/>
+          <a:p>
+            <a:r>
+              <a:rPr lang="es-ES" sz="1600" dirty="0" smtClean="0">
+                <a:solidFill>
+                  <a:schemeClr val="accent4">
+                    <a:lumMod val="75000"/>
+                  </a:schemeClr>
+                </a:solidFill>
+              </a:rPr>
+              <a:t>Production process</a:t>
+            </a:r>
+            <a:endParaRPr lang="es-ES" sz="1600" dirty="0">
+              <a:solidFill>
+                <a:schemeClr val="accent4">
+                  <a:lumMod val="75000"/>
+                </a:schemeClr>
+              </a:solidFill>
+            </a:endParaRPr>
+          </a:p>
+        </p:txBody>
+      </p:sp>
+      <p:cxnSp>
+        <p:nvCxnSpPr>
+          <p:cNvPr id="72" name="Conector recto 71"/>
+          <p:cNvCxnSpPr/>
+          <p:nvPr/>
+        </p:nvCxnSpPr>
+        <p:spPr>
+          <a:xfrm>
+            <a:off x="299978" y="6354346"/>
+            <a:ext cx="623843" cy="0"/>
+          </a:xfrm>
+          <a:prstGeom prst="line">
+            <a:avLst/>
+          </a:prstGeom>
+          <a:ln w="28575">
             <a:solidFill>
-              <a:schemeClr val="tx1"/>
+              <a:srgbClr val="FFC000"/>
             </a:solidFill>
           </a:ln>
         </p:spPr>
         <p:style>
-          <a:lnRef idx="2">
-            <a:schemeClr val="accent1">
-              <a:shade val="50000"/>
-            </a:schemeClr>
+          <a:lnRef idx="1">
+            <a:schemeClr val="accent1"/>
           </a:lnRef>
-          <a:fillRef idx="1">
+          <a:fillRef idx="0">
             <a:schemeClr val="accent1"/>
           </a:fillRef>
           <a:effectRef idx="0">
             <a:schemeClr val="accent1"/>
           </a:effectRef>
           <a:fontRef idx="minor">
-            <a:schemeClr val="lt1"/>
+            <a:schemeClr val="tx1"/>
           </a:fontRef>
         </p:style>
-        <p:txBody>
-          <a:bodyPr rtlCol="0" anchor="ctr"/>
-          <a:lstStyle/>
-          <a:p>
-            <a:pPr algn="ctr"/>
-            <a:endParaRPr lang="es-ES" dirty="0"/>
-          </a:p>
-        </p:txBody>
-      </p:sp>
+      </p:cxnSp>
     </p:spTree>
     <p:extLst>
       <p:ext uri="{BB962C8B-B14F-4D97-AF65-F5344CB8AC3E}">

</xml_diff>